<commit_message>
strip placeholder body content from all 5 templates
DOCX templates: deleted all body stubs (headings, tables, chart
placeholders, section placeholders) between cover page and final
sectPr. Cover page and footer placeholders preserved:
[CLIENT COMPANY NAME], [ENGAGEMENT DATE].

PPTX template: cleared bracket placeholder text on slides 2-11,
kept slide 1 title slide with [CLIENT COMPANY NAME] and [DATE].

Co-Authored-By: Claude Opus 4.6 (1M context) <noreply@anthropic.com>
</commit_message>
<xml_diff>
--- a/backend/templates/11_Presentation_Deck.pptx
+++ b/backend/templates/11_Presentation_Deck.pptx
@@ -2340,7 +2340,7 @@
                 <a:ea typeface="Calibri" pitchFamily="34" charset="-122"/>
                 <a:cs typeface="Calibri" pitchFamily="34" charset="-120"/>
               </a:rPr>
-              <a:t>George DeVries  |  george@baxterlabs.com  |  [PHONE]</a:t>
+              <a:t/>
             </a:r>
             <a:endParaRPr lang="en-US" sz="1200" dirty="0"/>
           </a:p>
@@ -2379,7 +2379,7 @@
                 <a:ea typeface="Calibri" pitchFamily="34" charset="-122"/>
                 <a:cs typeface="Calibri" pitchFamily="34" charset="-120"/>
               </a:rPr>
-              <a:t>Alfonso Cordon  |  alfonso@baxterlabs.com  |  [PHONE]</a:t>
+              <a:t/>
             </a:r>
             <a:endParaRPr lang="en-US" sz="1200" dirty="0"/>
           </a:p>
@@ -2657,7 +2657,7 @@
                 <a:ea typeface="Calibri" pitchFamily="34" charset="-122"/>
                 <a:cs typeface="Calibri" pitchFamily="34" charset="-120"/>
               </a:rPr>
-              <a:t>[INSERT: Detailed finding slides, workflow diagrams, financial model snapshots]</a:t>
+              <a:t/>
             </a:r>
             <a:endParaRPr lang="en-US" sz="1400" dirty="0"/>
           </a:p>
@@ -3799,7 +3799,7 @@
                 <a:ea typeface="Arial Black" pitchFamily="34" charset="-122"/>
                 <a:cs typeface="Arial Black" pitchFamily="34" charset="-120"/>
               </a:rPr>
-              <a:t>$[X,XXX,XXX]</a:t>
+              <a:t/>
             </a:r>
             <a:endParaRPr lang="en-US" sz="2800" dirty="0"/>
           </a:p>
@@ -3904,7 +3904,7 @@
                 <a:ea typeface="Arial Black" pitchFamily="34" charset="-122"/>
                 <a:cs typeface="Arial Black" pitchFamily="34" charset="-120"/>
               </a:rPr>
-              <a:t>[XX]%</a:t>
+              <a:t/>
             </a:r>
             <a:endParaRPr lang="en-US" sz="2800" dirty="0"/>
           </a:p>
@@ -4009,7 +4009,7 @@
                 <a:ea typeface="Arial Black" pitchFamily="34" charset="-122"/>
                 <a:cs typeface="Arial Black" pitchFamily="34" charset="-120"/>
               </a:rPr>
-              <a:t>[XX]%</a:t>
+              <a:t/>
             </a:r>
             <a:endParaRPr lang="en-US" sz="2800" dirty="0"/>
           </a:p>
@@ -4114,7 +4114,7 @@
                 <a:ea typeface="Arial Black" pitchFamily="34" charset="-122"/>
                 <a:cs typeface="Arial Black" pitchFamily="34" charset="-120"/>
               </a:rPr>
-              <a:t>[N] FTEs</a:t>
+              <a:t/>
             </a:r>
             <a:endParaRPr lang="en-US" sz="2800" dirty="0"/>
           </a:p>
@@ -4219,7 +4219,7 @@
                 <a:ea typeface="Arial Black" pitchFamily="34" charset="-122"/>
                 <a:cs typeface="Arial Black" pitchFamily="34" charset="-120"/>
               </a:rPr>
-              <a:t>$[XXX,XXX]</a:t>
+              <a:t/>
             </a:r>
             <a:endParaRPr lang="en-US" sz="2800" dirty="0"/>
           </a:p>
@@ -4324,7 +4324,7 @@
                 <a:ea typeface="Arial Black" pitchFamily="34" charset="-122"/>
                 <a:cs typeface="Arial Black" pitchFamily="34" charset="-120"/>
               </a:rPr>
-              <a:t>[XX]%</a:t>
+              <a:t/>
             </a:r>
             <a:endParaRPr lang="en-US" sz="2800" dirty="0"/>
           </a:p>
@@ -4402,7 +4402,7 @@
                 <a:ea typeface="Calibri" pitchFamily="34" charset="-122"/>
                 <a:cs typeface="Calibri" pitchFamily="34" charset="-120"/>
               </a:rPr>
-              <a:t>[COMPANY NAME]  |  Fiscal Year [YEAR]  |  BaxterLabs Advisory</a:t>
+              <a:t/>
             </a:r>
             <a:endParaRPr lang="en-US" sz="900" dirty="0"/>
           </a:p>
@@ -4922,7 +4922,7 @@
                 <a:ea typeface="Arial Black" pitchFamily="34" charset="-122"/>
                 <a:cs typeface="Arial Black" pitchFamily="34" charset="-120"/>
               </a:rPr>
-              <a:t>$[AMOUNT]</a:t>
+              <a:t/>
             </a:r>
             <a:endParaRPr lang="en-US" sz="2200" dirty="0"/>
           </a:p>
@@ -5079,7 +5079,7 @@
                 <a:ea typeface="Arial Black" pitchFamily="34" charset="-122"/>
                 <a:cs typeface="Arial Black" pitchFamily="34" charset="-120"/>
               </a:rPr>
-              <a:t>$[AMOUNT]</a:t>
+              <a:t/>
             </a:r>
             <a:endParaRPr lang="en-US" sz="2200" dirty="0"/>
           </a:p>
@@ -5236,7 +5236,7 @@
                 <a:ea typeface="Arial Black" pitchFamily="34" charset="-122"/>
                 <a:cs typeface="Arial Black" pitchFamily="34" charset="-120"/>
               </a:rPr>
-              <a:t>$[AMOUNT]</a:t>
+              <a:t/>
             </a:r>
             <a:endParaRPr lang="en-US" sz="2200" dirty="0"/>
           </a:p>
@@ -5393,7 +5393,7 @@
                 <a:ea typeface="Arial Black" pitchFamily="34" charset="-122"/>
                 <a:cs typeface="Arial Black" pitchFamily="34" charset="-120"/>
               </a:rPr>
-              <a:t>$[AMOUNT]</a:t>
+              <a:t/>
             </a:r>
             <a:endParaRPr lang="en-US" sz="2200" dirty="0"/>
           </a:p>
@@ -5550,7 +5550,7 @@
                 <a:ea typeface="Arial Black" pitchFamily="34" charset="-122"/>
                 <a:cs typeface="Arial Black" pitchFamily="34" charset="-120"/>
               </a:rPr>
-              <a:t>$[AMOUNT]</a:t>
+              <a:t/>
             </a:r>
             <a:endParaRPr lang="en-US" sz="2200" dirty="0"/>
           </a:p>
@@ -5648,7 +5648,7 @@
                 <a:ea typeface="Arial Black" pitchFamily="34" charset="-122"/>
                 <a:cs typeface="Arial Black" pitchFamily="34" charset="-120"/>
               </a:rPr>
-              <a:t>$[TOTAL AMOUNT]</a:t>
+              <a:t/>
             </a:r>
             <a:endParaRPr lang="en-US" sz="1800" dirty="0"/>
           </a:p>
@@ -6147,7 +6147,7 @@
                 <a:ea typeface="Calibri" pitchFamily="34" charset="-122"/>
                 <a:cs typeface="Calibri" pitchFamily="34" charset="-120"/>
               </a:rPr>
-              <a:t>[Action Item 1]</a:t>
+              <a:t/>
             </a:r>
             <a:endParaRPr lang="en-US" sz="1200" dirty="0"/>
           </a:p>
@@ -6197,7 +6197,7 @@
                 <a:ea typeface="Calibri" pitchFamily="34" charset="-122"/>
                 <a:cs typeface="Calibri" pitchFamily="34" charset="-120"/>
               </a:rPr>
-              <a:t>[Action Item 2]</a:t>
+              <a:t/>
             </a:r>
             <a:endParaRPr lang="en-US" sz="1200" dirty="0"/>
           </a:p>
@@ -6247,7 +6247,7 @@
                 <a:ea typeface="Calibri" pitchFamily="34" charset="-122"/>
                 <a:cs typeface="Calibri" pitchFamily="34" charset="-120"/>
               </a:rPr>
-              <a:t>[Action Item 3]</a:t>
+              <a:t/>
             </a:r>
             <a:endParaRPr lang="en-US" sz="1200" dirty="0"/>
           </a:p>
@@ -6306,7 +6306,7 @@
                 <a:ea typeface="Arial Black" pitchFamily="34" charset="-122"/>
                 <a:cs typeface="Arial Black" pitchFamily="34" charset="-120"/>
               </a:rPr>
-              <a:t>Est. Impact: $[AMOUNT]</a:t>
+              <a:t/>
             </a:r>
             <a:endParaRPr lang="en-US" sz="1300" dirty="0"/>
           </a:p>
@@ -6481,7 +6481,7 @@
                 <a:ea typeface="Calibri" pitchFamily="34" charset="-122"/>
                 <a:cs typeface="Calibri" pitchFamily="34" charset="-120"/>
               </a:rPr>
-              <a:t>[Action Item 1]</a:t>
+              <a:t/>
             </a:r>
             <a:endParaRPr lang="en-US" sz="1200" dirty="0"/>
           </a:p>
@@ -6531,7 +6531,7 @@
                 <a:ea typeface="Calibri" pitchFamily="34" charset="-122"/>
                 <a:cs typeface="Calibri" pitchFamily="34" charset="-120"/>
               </a:rPr>
-              <a:t>[Action Item 2]</a:t>
+              <a:t/>
             </a:r>
             <a:endParaRPr lang="en-US" sz="1200" dirty="0"/>
           </a:p>
@@ -6581,7 +6581,7 @@
                 <a:ea typeface="Calibri" pitchFamily="34" charset="-122"/>
                 <a:cs typeface="Calibri" pitchFamily="34" charset="-120"/>
               </a:rPr>
-              <a:t>[Action Item 3]</a:t>
+              <a:t/>
             </a:r>
             <a:endParaRPr lang="en-US" sz="1200" dirty="0"/>
           </a:p>
@@ -6640,7 +6640,7 @@
                 <a:ea typeface="Arial Black" pitchFamily="34" charset="-122"/>
                 <a:cs typeface="Arial Black" pitchFamily="34" charset="-120"/>
               </a:rPr>
-              <a:t>Est. Impact: $[AMOUNT]</a:t>
+              <a:t/>
             </a:r>
             <a:endParaRPr lang="en-US" sz="1300" dirty="0"/>
           </a:p>
@@ -6815,7 +6815,7 @@
                 <a:ea typeface="Calibri" pitchFamily="34" charset="-122"/>
                 <a:cs typeface="Calibri" pitchFamily="34" charset="-120"/>
               </a:rPr>
-              <a:t>[Action Item 1]</a:t>
+              <a:t/>
             </a:r>
             <a:endParaRPr lang="en-US" sz="1200" dirty="0"/>
           </a:p>
@@ -6865,7 +6865,7 @@
                 <a:ea typeface="Calibri" pitchFamily="34" charset="-122"/>
                 <a:cs typeface="Calibri" pitchFamily="34" charset="-120"/>
               </a:rPr>
-              <a:t>[Action Item 2]</a:t>
+              <a:t/>
             </a:r>
             <a:endParaRPr lang="en-US" sz="1200" dirty="0"/>
           </a:p>
@@ -6915,7 +6915,7 @@
                 <a:ea typeface="Calibri" pitchFamily="34" charset="-122"/>
                 <a:cs typeface="Calibri" pitchFamily="34" charset="-120"/>
               </a:rPr>
-              <a:t>[Action Item 3]</a:t>
+              <a:t/>
             </a:r>
             <a:endParaRPr lang="en-US" sz="1200" dirty="0"/>
           </a:p>
@@ -6974,7 +6974,7 @@
                 <a:ea typeface="Arial Black" pitchFamily="34" charset="-122"/>
                 <a:cs typeface="Arial Black" pitchFamily="34" charset="-120"/>
               </a:rPr>
-              <a:t>Est. Impact: $[AMOUNT]</a:t>
+              <a:t/>
             </a:r>
             <a:endParaRPr lang="en-US" sz="1300" dirty="0"/>
           </a:p>

</xml_diff>